<commit_message>
fix: readme and conclusions
</commit_message>
<xml_diff>
--- a/recursos/Simulador de Impacto Presupuestal.pptx
+++ b/recursos/Simulador de Impacto Presupuestal.pptx
@@ -328,7 +328,7 @@
             <a:fld id="{1D8BD707-D9CF-40AE-B4C6-C98DA3205C09}" type="datetimeFigureOut">
               <a:rPr lang="en-US" smtClean="0"/>
               <a:pPr/>
-              <a:t>7/12/2026</a:t>
+              <a:t>7/13/2026</a:t>
             </a:fld>
             <a:endParaRPr lang="en-US"/>
           </a:p>
@@ -493,7 +493,7 @@
             <a:fld id="{1D8BD707-D9CF-40AE-B4C6-C98DA3205C09}" type="datetimeFigureOut">
               <a:rPr lang="en-US" smtClean="0"/>
               <a:pPr/>
-              <a:t>7/12/2026</a:t>
+              <a:t>7/13/2026</a:t>
             </a:fld>
             <a:endParaRPr lang="en-US"/>
           </a:p>
@@ -668,7 +668,7 @@
             <a:fld id="{1D8BD707-D9CF-40AE-B4C6-C98DA3205C09}" type="datetimeFigureOut">
               <a:rPr lang="en-US" smtClean="0"/>
               <a:pPr/>
-              <a:t>7/12/2026</a:t>
+              <a:t>7/13/2026</a:t>
             </a:fld>
             <a:endParaRPr lang="en-US"/>
           </a:p>
@@ -833,7 +833,7 @@
             <a:fld id="{1D8BD707-D9CF-40AE-B4C6-C98DA3205C09}" type="datetimeFigureOut">
               <a:rPr lang="en-US" smtClean="0"/>
               <a:pPr/>
-              <a:t>7/12/2026</a:t>
+              <a:t>7/13/2026</a:t>
             </a:fld>
             <a:endParaRPr lang="en-US"/>
           </a:p>
@@ -1075,7 +1075,7 @@
             <a:fld id="{1D8BD707-D9CF-40AE-B4C6-C98DA3205C09}" type="datetimeFigureOut">
               <a:rPr lang="en-US" smtClean="0"/>
               <a:pPr/>
-              <a:t>7/12/2026</a:t>
+              <a:t>7/13/2026</a:t>
             </a:fld>
             <a:endParaRPr lang="en-US"/>
           </a:p>
@@ -1357,7 +1357,7 @@
             <a:fld id="{1D8BD707-D9CF-40AE-B4C6-C98DA3205C09}" type="datetimeFigureOut">
               <a:rPr lang="en-US" smtClean="0"/>
               <a:pPr/>
-              <a:t>7/12/2026</a:t>
+              <a:t>7/13/2026</a:t>
             </a:fld>
             <a:endParaRPr lang="en-US"/>
           </a:p>
@@ -1773,7 +1773,7 @@
             <a:fld id="{1D8BD707-D9CF-40AE-B4C6-C98DA3205C09}" type="datetimeFigureOut">
               <a:rPr lang="en-US" smtClean="0"/>
               <a:pPr/>
-              <a:t>7/12/2026</a:t>
+              <a:t>7/13/2026</a:t>
             </a:fld>
             <a:endParaRPr lang="en-US"/>
           </a:p>
@@ -1887,7 +1887,7 @@
             <a:fld id="{1D8BD707-D9CF-40AE-B4C6-C98DA3205C09}" type="datetimeFigureOut">
               <a:rPr lang="en-US" smtClean="0"/>
               <a:pPr/>
-              <a:t>7/12/2026</a:t>
+              <a:t>7/13/2026</a:t>
             </a:fld>
             <a:endParaRPr lang="en-US"/>
           </a:p>
@@ -1979,7 +1979,7 @@
             <a:fld id="{1D8BD707-D9CF-40AE-B4C6-C98DA3205C09}" type="datetimeFigureOut">
               <a:rPr lang="en-US" smtClean="0"/>
               <a:pPr/>
-              <a:t>7/12/2026</a:t>
+              <a:t>7/13/2026</a:t>
             </a:fld>
             <a:endParaRPr lang="en-US"/>
           </a:p>
@@ -2251,7 +2251,7 @@
             <a:fld id="{1D8BD707-D9CF-40AE-B4C6-C98DA3205C09}" type="datetimeFigureOut">
               <a:rPr lang="en-US" smtClean="0"/>
               <a:pPr/>
-              <a:t>7/12/2026</a:t>
+              <a:t>7/13/2026</a:t>
             </a:fld>
             <a:endParaRPr lang="en-US"/>
           </a:p>
@@ -2500,7 +2500,7 @@
             <a:fld id="{1D8BD707-D9CF-40AE-B4C6-C98DA3205C09}" type="datetimeFigureOut">
               <a:rPr lang="en-US" smtClean="0"/>
               <a:pPr/>
-              <a:t>7/12/2026</a:t>
+              <a:t>7/13/2026</a:t>
             </a:fld>
             <a:endParaRPr lang="en-US"/>
           </a:p>
@@ -2708,7 +2708,7 @@
             <a:fld id="{1D8BD707-D9CF-40AE-B4C6-C98DA3205C09}" type="datetimeFigureOut">
               <a:rPr lang="en-US" smtClean="0"/>
               <a:pPr/>
-              <a:t>7/12/2026</a:t>
+              <a:t>7/13/2026</a:t>
             </a:fld>
             <a:endParaRPr lang="en-US"/>
           </a:p>
@@ -3415,7 +3415,7 @@
         <p:spPr>
           <a:xfrm>
             <a:off x="8133750" y="5639248"/>
-            <a:ext cx="4013892" cy="1465659"/>
+            <a:ext cx="4013892" cy="1298497"/>
           </a:xfrm>
           <a:prstGeom prst="rect">
             <a:avLst/>
@@ -3433,7 +3433,7 @@
               </a:lnSpc>
             </a:pPr>
             <a:r>
-              <a:rPr lang="en-US" sz="2200">
+              <a:rPr lang="en-US" sz="2200" dirty="0">
                 <a:solidFill>
                   <a:srgbClr val="405449"/>
                 </a:solidFill>
@@ -3461,7 +3461,19 @@
                 <a:cs typeface="Arimo"/>
                 <a:sym typeface="Arimo"/>
               </a:rPr>
-              <a:t>Juan Feipe Jurado</a:t>
+              <a:t>Juan Felipe </a:t>
+            </a:r>
+            <a:r>
+              <a:rPr lang="en-US" sz="2200" dirty="0">
+                <a:solidFill>
+                  <a:srgbClr val="405449"/>
+                </a:solidFill>
+                <a:latin typeface="Arimo"/>
+                <a:ea typeface="Arimo"/>
+                <a:cs typeface="Arimo"/>
+                <a:sym typeface="Arimo"/>
+              </a:rPr>
+              <a:t>Jurado</a:t>
             </a:r>
           </a:p>
           <a:p>
@@ -3471,7 +3483,7 @@
               </a:lnSpc>
             </a:pPr>
             <a:r>
-              <a:rPr lang="en-US" sz="2200">
+              <a:rPr lang="en-US" sz="2200" dirty="0">
                 <a:solidFill>
                   <a:srgbClr val="405449"/>
                 </a:solidFill>

</xml_diff>